<commit_message>
fix: CRLF to LF for all launch scripts; update methodology with 2D->64D prosody embedding
</commit_message>
<xml_diff>
--- a/paper_draft/presentation.pptx
+++ b/paper_draft/presentation.pptx
@@ -1,29 +1,29 @@
 
 <file path=ppt/presentation.xml><?xml version="1.0" encoding="utf-8"?>
-<p:presentation xmlns:a="http://schemas.openxmlformats.org/drawingml/2006/main" xmlns:r="http://schemas.openxmlformats.org/officeDocument/2006/relationships" xmlns:p="http://schemas.openxmlformats.org/presentationml/2006/main" saveSubsetFonts="1" autoCompressPictures="0">
+<p:presentation xmlns:a="http://schemas.openxmlformats.org/drawingml/2006/main" xmlns:r="http://schemas.openxmlformats.org/officeDocument/2006/relationships" xmlns:p="http://schemas.openxmlformats.org/presentationml/2006/main" autoCompressPictures="0">
   <p:sldMasterIdLst>
     <p:sldMasterId id="2147483648" r:id="rId1"/>
   </p:sldMasterIdLst>
   <p:sldIdLst>
-    <p:sldId id="256" r:id="rId7"/>
-    <p:sldId id="257" r:id="rId8"/>
-    <p:sldId id="258" r:id="rId9"/>
-    <p:sldId id="259" r:id="rId10"/>
-    <p:sldId id="260" r:id="rId11"/>
-    <p:sldId id="261" r:id="rId12"/>
-    <p:sldId id="262" r:id="rId13"/>
-    <p:sldId id="263" r:id="rId14"/>
-    <p:sldId id="264" r:id="rId15"/>
-    <p:sldId id="265" r:id="rId16"/>
-    <p:sldId id="266" r:id="rId17"/>
-    <p:sldId id="267" r:id="rId18"/>
-    <p:sldId id="268" r:id="rId19"/>
-    <p:sldId id="269" r:id="rId20"/>
-    <p:sldId id="270" r:id="rId21"/>
-    <p:sldId id="271" r:id="rId22"/>
-    <p:sldId id="272" r:id="rId23"/>
+    <p:sldId id="256" r:id="rId3"/>
+    <p:sldId id="257" r:id="rId4"/>
+    <p:sldId id="258" r:id="rId5"/>
+    <p:sldId id="259" r:id="rId6"/>
+    <p:sldId id="260" r:id="rId7"/>
+    <p:sldId id="261" r:id="rId8"/>
+    <p:sldId id="262" r:id="rId9"/>
+    <p:sldId id="263" r:id="rId10"/>
+    <p:sldId id="264" r:id="rId11"/>
+    <p:sldId id="265" r:id="rId12"/>
+    <p:sldId id="266" r:id="rId13"/>
+    <p:sldId id="267" r:id="rId14"/>
+    <p:sldId id="268" r:id="rId15"/>
+    <p:sldId id="269" r:id="rId16"/>
+    <p:sldId id="270" r:id="rId17"/>
+    <p:sldId id="271" r:id="rId18"/>
+    <p:sldId id="272" r:id="rId19"/>
   </p:sldIdLst>
-  <p:sldSz cx="12191695" cy="6858000" type="screen4x3"/>
+  <p:sldSz cx="12191365" cy="6858000" type="screen4x3"/>
   <p:notesSz cx="6858000" cy="9144000"/>
   <p:defaultTextStyle>
     <a:defPPr>
@@ -120,6 +120,22 @@
       </a:defRPr>
     </a:lvl9pPr>
   </p:defaultTextStyle>
+  <p:extLst>
+    <p:ext uri="{EFAFB233-063F-42B5-8137-9DF3F51BA10A}">
+      <p15:sldGuideLst xmlns:p15="http://schemas.microsoft.com/office/powerpoint/2012/main">
+        <p15:guide id="1" orient="horz" pos="2160" userDrawn="1">
+          <p15:clr>
+            <a:srgbClr val="A4A3A4"/>
+          </p15:clr>
+        </p15:guide>
+        <p15:guide id="2" pos="2880" userDrawn="1">
+          <p15:clr>
+            <a:srgbClr val="A4A3A4"/>
+          </p15:clr>
+        </p15:guide>
+      </p15:sldGuideLst>
+    </p:ext>
+  </p:extLst>
 </p:presentation>
 </file>
 
@@ -304,7 +320,6 @@
           <a:p>
             <a:fld id="{5BCAD085-E8A6-8845-BD4E-CB4CCA059FC4}" type="datetimeFigureOut">
               <a:rPr lang="en-US" smtClean="0"/>
-              <a:t>1/27/13</a:t>
             </a:fld>
             <a:endParaRPr lang="en-US"/>
           </a:p>
@@ -346,18 +361,12 @@
           <a:p>
             <a:fld id="{C1FF6DA9-008F-8B48-92A6-B652298478BF}" type="slidenum">
               <a:rPr lang="en-US" smtClean="0"/>
-              <a:t>‹#›</a:t>
             </a:fld>
             <a:endParaRPr lang="en-US"/>
           </a:p>
         </p:txBody>
       </p:sp>
     </p:spTree>
-    <p:extLst>
-      <p:ext uri="{BB962C8B-B14F-4D97-AF65-F5344CB8AC3E}">
-        <p14:creationId xmlns:p14="http://schemas.microsoft.com/office/powerpoint/2010/main" val="3168075583"/>
-      </p:ext>
-    </p:extLst>
   </p:cSld>
   <p:clrMapOvr>
     <a:masterClrMapping/>
@@ -425,6 +434,7 @@
               <a:rPr lang="en-US" smtClean="0"/>
               <a:t>Click to edit Master text styles</a:t>
             </a:r>
+            <a:endParaRPr lang="en-US" smtClean="0"/>
           </a:p>
           <a:p>
             <a:pPr lvl="1"/>
@@ -432,6 +442,7 @@
               <a:rPr lang="en-US" smtClean="0"/>
               <a:t>Second level</a:t>
             </a:r>
+            <a:endParaRPr lang="en-US" smtClean="0"/>
           </a:p>
           <a:p>
             <a:pPr lvl="2"/>
@@ -439,6 +450,7 @@
               <a:rPr lang="en-US" smtClean="0"/>
               <a:t>Third level</a:t>
             </a:r>
+            <a:endParaRPr lang="en-US" smtClean="0"/>
           </a:p>
           <a:p>
             <a:pPr lvl="3"/>
@@ -446,6 +458,7 @@
               <a:rPr lang="en-US" smtClean="0"/>
               <a:t>Fourth level</a:t>
             </a:r>
+            <a:endParaRPr lang="en-US" smtClean="0"/>
           </a:p>
           <a:p>
             <a:pPr lvl="4"/>
@@ -474,7 +487,6 @@
           <a:p>
             <a:fld id="{5BCAD085-E8A6-8845-BD4E-CB4CCA059FC4}" type="datetimeFigureOut">
               <a:rPr lang="en-US" smtClean="0"/>
-              <a:t>1/27/13</a:t>
             </a:fld>
             <a:endParaRPr lang="en-US"/>
           </a:p>
@@ -516,18 +528,12 @@
           <a:p>
             <a:fld id="{C1FF6DA9-008F-8B48-92A6-B652298478BF}" type="slidenum">
               <a:rPr lang="en-US" smtClean="0"/>
-              <a:t>‹#›</a:t>
             </a:fld>
             <a:endParaRPr lang="en-US"/>
           </a:p>
         </p:txBody>
       </p:sp>
     </p:spTree>
-    <p:extLst>
-      <p:ext uri="{BB962C8B-B14F-4D97-AF65-F5344CB8AC3E}">
-        <p14:creationId xmlns:p14="http://schemas.microsoft.com/office/powerpoint/2010/main" val="2910927964"/>
-      </p:ext>
-    </p:extLst>
   </p:cSld>
   <p:clrMapOvr>
     <a:masterClrMapping/>
@@ -605,6 +611,7 @@
               <a:rPr lang="en-US" smtClean="0"/>
               <a:t>Click to edit Master text styles</a:t>
             </a:r>
+            <a:endParaRPr lang="en-US" smtClean="0"/>
           </a:p>
           <a:p>
             <a:pPr lvl="1"/>
@@ -612,6 +619,7 @@
               <a:rPr lang="en-US" smtClean="0"/>
               <a:t>Second level</a:t>
             </a:r>
+            <a:endParaRPr lang="en-US" smtClean="0"/>
           </a:p>
           <a:p>
             <a:pPr lvl="2"/>
@@ -619,6 +627,7 @@
               <a:rPr lang="en-US" smtClean="0"/>
               <a:t>Third level</a:t>
             </a:r>
+            <a:endParaRPr lang="en-US" smtClean="0"/>
           </a:p>
           <a:p>
             <a:pPr lvl="3"/>
@@ -626,6 +635,7 @@
               <a:rPr lang="en-US" smtClean="0"/>
               <a:t>Fourth level</a:t>
             </a:r>
+            <a:endParaRPr lang="en-US" smtClean="0"/>
           </a:p>
           <a:p>
             <a:pPr lvl="4"/>
@@ -654,7 +664,6 @@
           <a:p>
             <a:fld id="{5BCAD085-E8A6-8845-BD4E-CB4CCA059FC4}" type="datetimeFigureOut">
               <a:rPr lang="en-US" smtClean="0"/>
-              <a:t>1/27/13</a:t>
             </a:fld>
             <a:endParaRPr lang="en-US"/>
           </a:p>
@@ -696,18 +705,12 @@
           <a:p>
             <a:fld id="{C1FF6DA9-008F-8B48-92A6-B652298478BF}" type="slidenum">
               <a:rPr lang="en-US" smtClean="0"/>
-              <a:t>‹#›</a:t>
             </a:fld>
             <a:endParaRPr lang="en-US"/>
           </a:p>
         </p:txBody>
       </p:sp>
     </p:spTree>
-    <p:extLst>
-      <p:ext uri="{BB962C8B-B14F-4D97-AF65-F5344CB8AC3E}">
-        <p14:creationId xmlns:p14="http://schemas.microsoft.com/office/powerpoint/2010/main" val="3612223792"/>
-      </p:ext>
-    </p:extLst>
   </p:cSld>
   <p:clrMapOvr>
     <a:masterClrMapping/>
@@ -775,6 +778,7 @@
               <a:rPr lang="en-US" smtClean="0"/>
               <a:t>Click to edit Master text styles</a:t>
             </a:r>
+            <a:endParaRPr lang="en-US" smtClean="0"/>
           </a:p>
           <a:p>
             <a:pPr lvl="1"/>
@@ -782,6 +786,7 @@
               <a:rPr lang="en-US" smtClean="0"/>
               <a:t>Second level</a:t>
             </a:r>
+            <a:endParaRPr lang="en-US" smtClean="0"/>
           </a:p>
           <a:p>
             <a:pPr lvl="2"/>
@@ -789,6 +794,7 @@
               <a:rPr lang="en-US" smtClean="0"/>
               <a:t>Third level</a:t>
             </a:r>
+            <a:endParaRPr lang="en-US" smtClean="0"/>
           </a:p>
           <a:p>
             <a:pPr lvl="3"/>
@@ -796,6 +802,7 @@
               <a:rPr lang="en-US" smtClean="0"/>
               <a:t>Fourth level</a:t>
             </a:r>
+            <a:endParaRPr lang="en-US" smtClean="0"/>
           </a:p>
           <a:p>
             <a:pPr lvl="4"/>
@@ -824,7 +831,6 @@
           <a:p>
             <a:fld id="{5BCAD085-E8A6-8845-BD4E-CB4CCA059FC4}" type="datetimeFigureOut">
               <a:rPr lang="en-US" smtClean="0"/>
-              <a:t>1/27/13</a:t>
             </a:fld>
             <a:endParaRPr lang="en-US"/>
           </a:p>
@@ -866,18 +872,12 @@
           <a:p>
             <a:fld id="{C1FF6DA9-008F-8B48-92A6-B652298478BF}" type="slidenum">
               <a:rPr lang="en-US" smtClean="0"/>
-              <a:t>‹#›</a:t>
             </a:fld>
             <a:endParaRPr lang="en-US"/>
           </a:p>
         </p:txBody>
       </p:sp>
     </p:spTree>
-    <p:extLst>
-      <p:ext uri="{BB962C8B-B14F-4D97-AF65-F5344CB8AC3E}">
-        <p14:creationId xmlns:p14="http://schemas.microsoft.com/office/powerpoint/2010/main" val="2614314258"/>
-      </p:ext>
-    </p:extLst>
   </p:cSld>
   <p:clrMapOvr>
     <a:masterClrMapping/>
@@ -1050,6 +1050,7 @@
               <a:rPr lang="en-US" smtClean="0"/>
               <a:t>Click to edit Master text styles</a:t>
             </a:r>
+            <a:endParaRPr lang="en-US" smtClean="0"/>
           </a:p>
         </p:txBody>
       </p:sp>
@@ -1070,7 +1071,6 @@
           <a:p>
             <a:fld id="{5BCAD085-E8A6-8845-BD4E-CB4CCA059FC4}" type="datetimeFigureOut">
               <a:rPr lang="en-US" smtClean="0"/>
-              <a:t>1/27/13</a:t>
             </a:fld>
             <a:endParaRPr lang="en-US"/>
           </a:p>
@@ -1112,18 +1112,12 @@
           <a:p>
             <a:fld id="{C1FF6DA9-008F-8B48-92A6-B652298478BF}" type="slidenum">
               <a:rPr lang="en-US" smtClean="0"/>
-              <a:t>‹#›</a:t>
             </a:fld>
             <a:endParaRPr lang="en-US"/>
           </a:p>
         </p:txBody>
       </p:sp>
     </p:spTree>
-    <p:extLst>
-      <p:ext uri="{BB962C8B-B14F-4D97-AF65-F5344CB8AC3E}">
-        <p14:creationId xmlns:p14="http://schemas.microsoft.com/office/powerpoint/2010/main" val="960648375"/>
-      </p:ext>
-    </p:extLst>
   </p:cSld>
   <p:clrMapOvr>
     <a:masterClrMapping/>
@@ -1224,6 +1218,7 @@
               <a:rPr lang="en-US" smtClean="0"/>
               <a:t>Click to edit Master text styles</a:t>
             </a:r>
+            <a:endParaRPr lang="en-US" smtClean="0"/>
           </a:p>
           <a:p>
             <a:pPr lvl="1"/>
@@ -1231,6 +1226,7 @@
               <a:rPr lang="en-US" smtClean="0"/>
               <a:t>Second level</a:t>
             </a:r>
+            <a:endParaRPr lang="en-US" smtClean="0"/>
           </a:p>
           <a:p>
             <a:pPr lvl="2"/>
@@ -1238,6 +1234,7 @@
               <a:rPr lang="en-US" smtClean="0"/>
               <a:t>Third level</a:t>
             </a:r>
+            <a:endParaRPr lang="en-US" smtClean="0"/>
           </a:p>
           <a:p>
             <a:pPr lvl="3"/>
@@ -1245,6 +1242,7 @@
               <a:rPr lang="en-US" smtClean="0"/>
               <a:t>Fourth level</a:t>
             </a:r>
+            <a:endParaRPr lang="en-US" smtClean="0"/>
           </a:p>
           <a:p>
             <a:pPr lvl="4"/>
@@ -1309,6 +1307,7 @@
               <a:rPr lang="en-US" smtClean="0"/>
               <a:t>Click to edit Master text styles</a:t>
             </a:r>
+            <a:endParaRPr lang="en-US" smtClean="0"/>
           </a:p>
           <a:p>
             <a:pPr lvl="1"/>
@@ -1316,6 +1315,7 @@
               <a:rPr lang="en-US" smtClean="0"/>
               <a:t>Second level</a:t>
             </a:r>
+            <a:endParaRPr lang="en-US" smtClean="0"/>
           </a:p>
           <a:p>
             <a:pPr lvl="2"/>
@@ -1323,6 +1323,7 @@
               <a:rPr lang="en-US" smtClean="0"/>
               <a:t>Third level</a:t>
             </a:r>
+            <a:endParaRPr lang="en-US" smtClean="0"/>
           </a:p>
           <a:p>
             <a:pPr lvl="3"/>
@@ -1330,6 +1331,7 @@
               <a:rPr lang="en-US" smtClean="0"/>
               <a:t>Fourth level</a:t>
             </a:r>
+            <a:endParaRPr lang="en-US" smtClean="0"/>
           </a:p>
           <a:p>
             <a:pPr lvl="4"/>
@@ -1358,7 +1360,6 @@
           <a:p>
             <a:fld id="{5BCAD085-E8A6-8845-BD4E-CB4CCA059FC4}" type="datetimeFigureOut">
               <a:rPr lang="en-US" smtClean="0"/>
-              <a:t>1/27/13</a:t>
             </a:fld>
             <a:endParaRPr lang="en-US"/>
           </a:p>
@@ -1400,18 +1401,12 @@
           <a:p>
             <a:fld id="{C1FF6DA9-008F-8B48-92A6-B652298478BF}" type="slidenum">
               <a:rPr lang="en-US" smtClean="0"/>
-              <a:t>‹#›</a:t>
             </a:fld>
             <a:endParaRPr lang="en-US"/>
           </a:p>
         </p:txBody>
       </p:sp>
     </p:spTree>
-    <p:extLst>
-      <p:ext uri="{BB962C8B-B14F-4D97-AF65-F5344CB8AC3E}">
-        <p14:creationId xmlns:p14="http://schemas.microsoft.com/office/powerpoint/2010/main" val="2782244947"/>
-      </p:ext>
-    </p:extLst>
   </p:cSld>
   <p:clrMapOvr>
     <a:masterClrMapping/>
@@ -1525,6 +1520,7 @@
               <a:rPr lang="en-US" smtClean="0"/>
               <a:t>Click to edit Master text styles</a:t>
             </a:r>
+            <a:endParaRPr lang="en-US" smtClean="0"/>
           </a:p>
         </p:txBody>
       </p:sp>
@@ -1581,6 +1577,7 @@
               <a:rPr lang="en-US" smtClean="0"/>
               <a:t>Click to edit Master text styles</a:t>
             </a:r>
+            <a:endParaRPr lang="en-US" smtClean="0"/>
           </a:p>
           <a:p>
             <a:pPr lvl="1"/>
@@ -1588,6 +1585,7 @@
               <a:rPr lang="en-US" smtClean="0"/>
               <a:t>Second level</a:t>
             </a:r>
+            <a:endParaRPr lang="en-US" smtClean="0"/>
           </a:p>
           <a:p>
             <a:pPr lvl="2"/>
@@ -1595,6 +1593,7 @@
               <a:rPr lang="en-US" smtClean="0"/>
               <a:t>Third level</a:t>
             </a:r>
+            <a:endParaRPr lang="en-US" smtClean="0"/>
           </a:p>
           <a:p>
             <a:pPr lvl="3"/>
@@ -1602,6 +1601,7 @@
               <a:rPr lang="en-US" smtClean="0"/>
               <a:t>Fourth level</a:t>
             </a:r>
+            <a:endParaRPr lang="en-US" smtClean="0"/>
           </a:p>
           <a:p>
             <a:pPr lvl="4"/>
@@ -1675,6 +1675,7 @@
               <a:rPr lang="en-US" smtClean="0"/>
               <a:t>Click to edit Master text styles</a:t>
             </a:r>
+            <a:endParaRPr lang="en-US" smtClean="0"/>
           </a:p>
         </p:txBody>
       </p:sp>
@@ -1731,6 +1732,7 @@
               <a:rPr lang="en-US" smtClean="0"/>
               <a:t>Click to edit Master text styles</a:t>
             </a:r>
+            <a:endParaRPr lang="en-US" smtClean="0"/>
           </a:p>
           <a:p>
             <a:pPr lvl="1"/>
@@ -1738,6 +1740,7 @@
               <a:rPr lang="en-US" smtClean="0"/>
               <a:t>Second level</a:t>
             </a:r>
+            <a:endParaRPr lang="en-US" smtClean="0"/>
           </a:p>
           <a:p>
             <a:pPr lvl="2"/>
@@ -1745,6 +1748,7 @@
               <a:rPr lang="en-US" smtClean="0"/>
               <a:t>Third level</a:t>
             </a:r>
+            <a:endParaRPr lang="en-US" smtClean="0"/>
           </a:p>
           <a:p>
             <a:pPr lvl="3"/>
@@ -1752,6 +1756,7 @@
               <a:rPr lang="en-US" smtClean="0"/>
               <a:t>Fourth level</a:t>
             </a:r>
+            <a:endParaRPr lang="en-US" smtClean="0"/>
           </a:p>
           <a:p>
             <a:pPr lvl="4"/>
@@ -1780,7 +1785,6 @@
           <a:p>
             <a:fld id="{5BCAD085-E8A6-8845-BD4E-CB4CCA059FC4}" type="datetimeFigureOut">
               <a:rPr lang="en-US" smtClean="0"/>
-              <a:t>1/27/13</a:t>
             </a:fld>
             <a:endParaRPr lang="en-US"/>
           </a:p>
@@ -1822,18 +1826,12 @@
           <a:p>
             <a:fld id="{C1FF6DA9-008F-8B48-92A6-B652298478BF}" type="slidenum">
               <a:rPr lang="en-US" smtClean="0"/>
-              <a:t>‹#›</a:t>
             </a:fld>
             <a:endParaRPr lang="en-US"/>
           </a:p>
         </p:txBody>
       </p:sp>
     </p:spTree>
-    <p:extLst>
-      <p:ext uri="{BB962C8B-B14F-4D97-AF65-F5344CB8AC3E}">
-        <p14:creationId xmlns:p14="http://schemas.microsoft.com/office/powerpoint/2010/main" val="990158736"/>
-      </p:ext>
-    </p:extLst>
   </p:cSld>
   <p:clrMapOvr>
     <a:masterClrMapping/>
@@ -1898,7 +1896,6 @@
           <a:p>
             <a:fld id="{5BCAD085-E8A6-8845-BD4E-CB4CCA059FC4}" type="datetimeFigureOut">
               <a:rPr lang="en-US" smtClean="0"/>
-              <a:t>1/27/13</a:t>
             </a:fld>
             <a:endParaRPr lang="en-US"/>
           </a:p>
@@ -1940,18 +1937,12 @@
           <a:p>
             <a:fld id="{C1FF6DA9-008F-8B48-92A6-B652298478BF}" type="slidenum">
               <a:rPr lang="en-US" smtClean="0"/>
-              <a:t>‹#›</a:t>
             </a:fld>
             <a:endParaRPr lang="en-US"/>
           </a:p>
         </p:txBody>
       </p:sp>
     </p:spTree>
-    <p:extLst>
-      <p:ext uri="{BB962C8B-B14F-4D97-AF65-F5344CB8AC3E}">
-        <p14:creationId xmlns:p14="http://schemas.microsoft.com/office/powerpoint/2010/main" val="727027711"/>
-      </p:ext>
-    </p:extLst>
   </p:cSld>
   <p:clrMapOvr>
     <a:masterClrMapping/>
@@ -1993,7 +1984,6 @@
           <a:p>
             <a:fld id="{5BCAD085-E8A6-8845-BD4E-CB4CCA059FC4}" type="datetimeFigureOut">
               <a:rPr lang="en-US" smtClean="0"/>
-              <a:t>1/27/13</a:t>
             </a:fld>
             <a:endParaRPr lang="en-US"/>
           </a:p>
@@ -2035,18 +2025,12 @@
           <a:p>
             <a:fld id="{C1FF6DA9-008F-8B48-92A6-B652298478BF}" type="slidenum">
               <a:rPr lang="en-US" smtClean="0"/>
-              <a:t>‹#›</a:t>
             </a:fld>
             <a:endParaRPr lang="en-US"/>
           </a:p>
         </p:txBody>
       </p:sp>
     </p:spTree>
-    <p:extLst>
-      <p:ext uri="{BB962C8B-B14F-4D97-AF65-F5344CB8AC3E}">
-        <p14:creationId xmlns:p14="http://schemas.microsoft.com/office/powerpoint/2010/main" val="1212999818"/>
-      </p:ext>
-    </p:extLst>
   </p:cSld>
   <p:clrMapOvr>
     <a:masterClrMapping/>
@@ -2156,6 +2140,7 @@
               <a:rPr lang="en-US" smtClean="0"/>
               <a:t>Click to edit Master text styles</a:t>
             </a:r>
+            <a:endParaRPr lang="en-US" smtClean="0"/>
           </a:p>
           <a:p>
             <a:pPr lvl="1"/>
@@ -2163,6 +2148,7 @@
               <a:rPr lang="en-US" smtClean="0"/>
               <a:t>Second level</a:t>
             </a:r>
+            <a:endParaRPr lang="en-US" smtClean="0"/>
           </a:p>
           <a:p>
             <a:pPr lvl="2"/>
@@ -2170,6 +2156,7 @@
               <a:rPr lang="en-US" smtClean="0"/>
               <a:t>Third level</a:t>
             </a:r>
+            <a:endParaRPr lang="en-US" smtClean="0"/>
           </a:p>
           <a:p>
             <a:pPr lvl="3"/>
@@ -2177,6 +2164,7 @@
               <a:rPr lang="en-US" smtClean="0"/>
               <a:t>Fourth level</a:t>
             </a:r>
+            <a:endParaRPr lang="en-US" smtClean="0"/>
           </a:p>
           <a:p>
             <a:pPr lvl="4"/>
@@ -2250,6 +2238,7 @@
               <a:rPr lang="en-US" smtClean="0"/>
               <a:t>Click to edit Master text styles</a:t>
             </a:r>
+            <a:endParaRPr lang="en-US" smtClean="0"/>
           </a:p>
         </p:txBody>
       </p:sp>
@@ -2270,7 +2259,6 @@
           <a:p>
             <a:fld id="{5BCAD085-E8A6-8845-BD4E-CB4CCA059FC4}" type="datetimeFigureOut">
               <a:rPr lang="en-US" smtClean="0"/>
-              <a:t>1/27/13</a:t>
             </a:fld>
             <a:endParaRPr lang="en-US"/>
           </a:p>
@@ -2312,18 +2300,12 @@
           <a:p>
             <a:fld id="{C1FF6DA9-008F-8B48-92A6-B652298478BF}" type="slidenum">
               <a:rPr lang="en-US" smtClean="0"/>
-              <a:t>‹#›</a:t>
             </a:fld>
             <a:endParaRPr lang="en-US"/>
           </a:p>
         </p:txBody>
       </p:sp>
     </p:spTree>
-    <p:extLst>
-      <p:ext uri="{BB962C8B-B14F-4D97-AF65-F5344CB8AC3E}">
-        <p14:creationId xmlns:p14="http://schemas.microsoft.com/office/powerpoint/2010/main" val="1840726560"/>
-      </p:ext>
-    </p:extLst>
   </p:cSld>
   <p:clrMapOvr>
     <a:masterClrMapping/>
@@ -2503,6 +2485,7 @@
               <a:rPr lang="en-US" smtClean="0"/>
               <a:t>Click to edit Master text styles</a:t>
             </a:r>
+            <a:endParaRPr lang="en-US" smtClean="0"/>
           </a:p>
         </p:txBody>
       </p:sp>
@@ -2523,7 +2506,6 @@
           <a:p>
             <a:fld id="{5BCAD085-E8A6-8845-BD4E-CB4CCA059FC4}" type="datetimeFigureOut">
               <a:rPr lang="en-US" smtClean="0"/>
-              <a:t>1/27/13</a:t>
             </a:fld>
             <a:endParaRPr lang="en-US"/>
           </a:p>
@@ -2565,18 +2547,12 @@
           <a:p>
             <a:fld id="{C1FF6DA9-008F-8B48-92A6-B652298478BF}" type="slidenum">
               <a:rPr lang="en-US" smtClean="0"/>
-              <a:t>‹#›</a:t>
             </a:fld>
             <a:endParaRPr lang="en-US"/>
           </a:p>
         </p:txBody>
       </p:sp>
     </p:spTree>
-    <p:extLst>
-      <p:ext uri="{BB962C8B-B14F-4D97-AF65-F5344CB8AC3E}">
-        <p14:creationId xmlns:p14="http://schemas.microsoft.com/office/powerpoint/2010/main" val="3889236939"/>
-      </p:ext>
-    </p:extLst>
   </p:cSld>
   <p:clrMapOvr>
     <a:masterClrMapping/>
@@ -2669,6 +2645,7 @@
               <a:rPr lang="en-US" smtClean="0"/>
               <a:t>Click to edit Master text styles</a:t>
             </a:r>
+            <a:endParaRPr lang="en-US" smtClean="0"/>
           </a:p>
           <a:p>
             <a:pPr lvl="1"/>
@@ -2676,6 +2653,7 @@
               <a:rPr lang="en-US" smtClean="0"/>
               <a:t>Second level</a:t>
             </a:r>
+            <a:endParaRPr lang="en-US" smtClean="0"/>
           </a:p>
           <a:p>
             <a:pPr lvl="2"/>
@@ -2683,6 +2661,7 @@
               <a:rPr lang="en-US" smtClean="0"/>
               <a:t>Third level</a:t>
             </a:r>
+            <a:endParaRPr lang="en-US" smtClean="0"/>
           </a:p>
           <a:p>
             <a:pPr lvl="3"/>
@@ -2690,6 +2669,7 @@
               <a:rPr lang="en-US" smtClean="0"/>
               <a:t>Fourth level</a:t>
             </a:r>
+            <a:endParaRPr lang="en-US" smtClean="0"/>
           </a:p>
           <a:p>
             <a:pPr lvl="4"/>
@@ -2736,7 +2716,6 @@
           <a:p>
             <a:fld id="{5BCAD085-E8A6-8845-BD4E-CB4CCA059FC4}" type="datetimeFigureOut">
               <a:rPr lang="en-US" smtClean="0"/>
-              <a:t>1/27/13</a:t>
             </a:fld>
             <a:endParaRPr lang="en-US"/>
           </a:p>
@@ -2814,18 +2793,12 @@
           <a:p>
             <a:fld id="{C1FF6DA9-008F-8B48-92A6-B652298478BF}" type="slidenum">
               <a:rPr lang="en-US" smtClean="0"/>
-              <a:t>‹#›</a:t>
             </a:fld>
             <a:endParaRPr lang="en-US"/>
           </a:p>
         </p:txBody>
       </p:sp>
     </p:spTree>
-    <p:extLst>
-      <p:ext uri="{BB962C8B-B14F-4D97-AF65-F5344CB8AC3E}">
-        <p14:creationId xmlns:p14="http://schemas.microsoft.com/office/powerpoint/2010/main" val="2209977519"/>
-      </p:ext>
-    </p:extLst>
   </p:cSld>
   <p:clrMap bg1="lt1" tx1="dk1" bg2="lt2" tx2="dk2" accent1="accent1" accent2="accent2" accent3="accent3" accent4="accent4" accent5="accent5" accent6="accent6" hlink="hlink" folHlink="folHlink"/>
   <p:sldLayoutIdLst>
@@ -2863,7 +2836,7 @@
         <a:spcBef>
           <a:spcPct val="20000"/>
         </a:spcBef>
-        <a:buFont typeface="Arial"/>
+        <a:buFont typeface="Arial" panose="020B0604020202020204"/>
         <a:buChar char="•"/>
         <a:defRPr sz="3200" kern="1200">
           <a:solidFill>
@@ -2878,7 +2851,7 @@
         <a:spcBef>
           <a:spcPct val="20000"/>
         </a:spcBef>
-        <a:buFont typeface="Arial"/>
+        <a:buFont typeface="Arial" panose="020B0604020202020204"/>
         <a:buChar char="–"/>
         <a:defRPr sz="2800" kern="1200">
           <a:solidFill>
@@ -2893,7 +2866,7 @@
         <a:spcBef>
           <a:spcPct val="20000"/>
         </a:spcBef>
-        <a:buFont typeface="Arial"/>
+        <a:buFont typeface="Arial" panose="020B0604020202020204"/>
         <a:buChar char="•"/>
         <a:defRPr sz="2400" kern="1200">
           <a:solidFill>
@@ -2908,7 +2881,7 @@
         <a:spcBef>
           <a:spcPct val="20000"/>
         </a:spcBef>
-        <a:buFont typeface="Arial"/>
+        <a:buFont typeface="Arial" panose="020B0604020202020204"/>
         <a:buChar char="–"/>
         <a:defRPr sz="2000" kern="1200">
           <a:solidFill>
@@ -2923,7 +2896,7 @@
         <a:spcBef>
           <a:spcPct val="20000"/>
         </a:spcBef>
-        <a:buFont typeface="Arial"/>
+        <a:buFont typeface="Arial" panose="020B0604020202020204"/>
         <a:buChar char="»"/>
         <a:defRPr sz="2000" kern="1200">
           <a:solidFill>
@@ -2938,7 +2911,7 @@
         <a:spcBef>
           <a:spcPct val="20000"/>
         </a:spcBef>
-        <a:buFont typeface="Arial"/>
+        <a:buFont typeface="Arial" panose="020B0604020202020204"/>
         <a:buChar char="•"/>
         <a:defRPr sz="2000" kern="1200">
           <a:solidFill>
@@ -2953,7 +2926,7 @@
         <a:spcBef>
           <a:spcPct val="20000"/>
         </a:spcBef>
-        <a:buFont typeface="Arial"/>
+        <a:buFont typeface="Arial" panose="020B0604020202020204"/>
         <a:buChar char="•"/>
         <a:defRPr sz="2000" kern="1200">
           <a:solidFill>
@@ -2968,7 +2941,7 @@
         <a:spcBef>
           <a:spcPct val="20000"/>
         </a:spcBef>
-        <a:buFont typeface="Arial"/>
+        <a:buFont typeface="Arial" panose="020B0604020202020204"/>
         <a:buChar char="•"/>
         <a:defRPr sz="2000" kern="1200">
           <a:solidFill>
@@ -2983,7 +2956,7 @@
         <a:spcBef>
           <a:spcPct val="20000"/>
         </a:spcBef>
-        <a:buFont typeface="Arial"/>
+        <a:buFont typeface="Arial" panose="020B0604020202020204"/>
         <a:buChar char="•"/>
         <a:defRPr sz="2000" kern="1200">
           <a:solidFill>
@@ -3095,7 +3068,7 @@
 </file>
 
 <file path=ppt/slides/slide1.xml><?xml version="1.0" encoding="utf-8"?>
-<p:sld xmlns:a="http://schemas.openxmlformats.org/drawingml/2006/main" xmlns:p="http://schemas.openxmlformats.org/presentationml/2006/main" xmlns:r="http://schemas.openxmlformats.org/officeDocument/2006/relationships">
+<p:sld xmlns:a="http://schemas.openxmlformats.org/drawingml/2006/main" xmlns:r="http://schemas.openxmlformats.org/officeDocument/2006/relationships" xmlns:p="http://schemas.openxmlformats.org/presentationml/2006/main">
   <p:cSld>
     <p:bg>
       <p:bgPr>
@@ -3192,7 +3165,7 @@
 </file>
 
 <file path=ppt/slides/slide10.xml><?xml version="1.0" encoding="utf-8"?>
-<p:sld xmlns:a="http://schemas.openxmlformats.org/drawingml/2006/main" xmlns:p="http://schemas.openxmlformats.org/presentationml/2006/main" xmlns:r="http://schemas.openxmlformats.org/officeDocument/2006/relationships">
+<p:sld xmlns:a="http://schemas.openxmlformats.org/drawingml/2006/main" xmlns:r="http://schemas.openxmlformats.org/officeDocument/2006/relationships" xmlns:p="http://schemas.openxmlformats.org/presentationml/2006/main">
   <p:cSld>
     <p:bg>
       <p:bgPr>
@@ -3253,7 +3226,7 @@
 </file>
 
 <file path=ppt/slides/slide11.xml><?xml version="1.0" encoding="utf-8"?>
-<p:sld xmlns:a="http://schemas.openxmlformats.org/drawingml/2006/main" xmlns:p="http://schemas.openxmlformats.org/presentationml/2006/main" xmlns:r="http://schemas.openxmlformats.org/officeDocument/2006/relationships">
+<p:sld xmlns:a="http://schemas.openxmlformats.org/drawingml/2006/main" xmlns:r="http://schemas.openxmlformats.org/officeDocument/2006/relationships" xmlns:p="http://schemas.openxmlformats.org/presentationml/2006/main">
   <p:cSld>
     <p:bg>
       <p:bgPr>
@@ -3382,7 +3355,7 @@
 </file>
 
 <file path=ppt/slides/slide12.xml><?xml version="1.0" encoding="utf-8"?>
-<p:sld xmlns:a="http://schemas.openxmlformats.org/drawingml/2006/main" xmlns:p="http://schemas.openxmlformats.org/presentationml/2006/main" xmlns:r="http://schemas.openxmlformats.org/officeDocument/2006/relationships">
+<p:sld xmlns:a="http://schemas.openxmlformats.org/drawingml/2006/main" xmlns:r="http://schemas.openxmlformats.org/officeDocument/2006/relationships" xmlns:p="http://schemas.openxmlformats.org/presentationml/2006/main">
   <p:cSld>
     <p:bg>
       <p:bgPr>
@@ -3526,7 +3499,7 @@
 </file>
 
 <file path=ppt/slides/slide13.xml><?xml version="1.0" encoding="utf-8"?>
-<p:sld xmlns:a="http://schemas.openxmlformats.org/drawingml/2006/main" xmlns:p="http://schemas.openxmlformats.org/presentationml/2006/main" xmlns:r="http://schemas.openxmlformats.org/officeDocument/2006/relationships">
+<p:sld xmlns:a="http://schemas.openxmlformats.org/drawingml/2006/main" xmlns:r="http://schemas.openxmlformats.org/officeDocument/2006/relationships" xmlns:p="http://schemas.openxmlformats.org/presentationml/2006/main">
   <p:cSld>
     <p:bg>
       <p:bgPr>
@@ -3655,7 +3628,7 @@
 </file>
 
 <file path=ppt/slides/slide14.xml><?xml version="1.0" encoding="utf-8"?>
-<p:sld xmlns:a="http://schemas.openxmlformats.org/drawingml/2006/main" xmlns:p="http://schemas.openxmlformats.org/presentationml/2006/main" xmlns:r="http://schemas.openxmlformats.org/officeDocument/2006/relationships">
+<p:sld xmlns:a="http://schemas.openxmlformats.org/drawingml/2006/main" xmlns:r="http://schemas.openxmlformats.org/officeDocument/2006/relationships" xmlns:p="http://schemas.openxmlformats.org/presentationml/2006/main">
   <p:cSld>
     <p:bg>
       <p:bgPr>
@@ -3716,7 +3689,7 @@
 </file>
 
 <file path=ppt/slides/slide15.xml><?xml version="1.0" encoding="utf-8"?>
-<p:sld xmlns:a="http://schemas.openxmlformats.org/drawingml/2006/main" xmlns:p="http://schemas.openxmlformats.org/presentationml/2006/main" xmlns:r="http://schemas.openxmlformats.org/officeDocument/2006/relationships">
+<p:sld xmlns:a="http://schemas.openxmlformats.org/drawingml/2006/main" xmlns:r="http://schemas.openxmlformats.org/officeDocument/2006/relationships" xmlns:p="http://schemas.openxmlformats.org/presentationml/2006/main">
   <p:cSld>
     <p:bg>
       <p:bgPr>
@@ -3860,7 +3833,7 @@
 </file>
 
 <file path=ppt/slides/slide16.xml><?xml version="1.0" encoding="utf-8"?>
-<p:sld xmlns:a="http://schemas.openxmlformats.org/drawingml/2006/main" xmlns:p="http://schemas.openxmlformats.org/presentationml/2006/main" xmlns:r="http://schemas.openxmlformats.org/officeDocument/2006/relationships">
+<p:sld xmlns:a="http://schemas.openxmlformats.org/drawingml/2006/main" xmlns:r="http://schemas.openxmlformats.org/officeDocument/2006/relationships" xmlns:p="http://schemas.openxmlformats.org/presentationml/2006/main">
   <p:cSld>
     <p:bg>
       <p:bgPr>
@@ -3921,7 +3894,7 @@
 </file>
 
 <file path=ppt/slides/slide17.xml><?xml version="1.0" encoding="utf-8"?>
-<p:sld xmlns:a="http://schemas.openxmlformats.org/drawingml/2006/main" xmlns:p="http://schemas.openxmlformats.org/presentationml/2006/main" xmlns:r="http://schemas.openxmlformats.org/officeDocument/2006/relationships">
+<p:sld xmlns:a="http://schemas.openxmlformats.org/drawingml/2006/main" xmlns:r="http://schemas.openxmlformats.org/officeDocument/2006/relationships" xmlns:p="http://schemas.openxmlformats.org/presentationml/2006/main">
   <p:cSld>
     <p:bg>
       <p:bgPr>
@@ -4107,7 +4080,7 @@
 </file>
 
 <file path=ppt/slides/slide2.xml><?xml version="1.0" encoding="utf-8"?>
-<p:sld xmlns:a="http://schemas.openxmlformats.org/drawingml/2006/main" xmlns:p="http://schemas.openxmlformats.org/presentationml/2006/main" xmlns:r="http://schemas.openxmlformats.org/officeDocument/2006/relationships">
+<p:sld xmlns:a="http://schemas.openxmlformats.org/drawingml/2006/main" xmlns:r="http://schemas.openxmlformats.org/officeDocument/2006/relationships" xmlns:p="http://schemas.openxmlformats.org/presentationml/2006/main">
   <p:cSld>
     <p:bg>
       <p:bgPr>
@@ -4168,7 +4141,7 @@
 </file>
 
 <file path=ppt/slides/slide3.xml><?xml version="1.0" encoding="utf-8"?>
-<p:sld xmlns:a="http://schemas.openxmlformats.org/drawingml/2006/main" xmlns:p="http://schemas.openxmlformats.org/presentationml/2006/main" xmlns:r="http://schemas.openxmlformats.org/officeDocument/2006/relationships">
+<p:sld xmlns:a="http://schemas.openxmlformats.org/drawingml/2006/main" xmlns:r="http://schemas.openxmlformats.org/officeDocument/2006/relationships" xmlns:p="http://schemas.openxmlformats.org/presentationml/2006/main">
   <p:cSld>
     <p:bg>
       <p:bgPr>
@@ -4312,7 +4285,7 @@
 </file>
 
 <file path=ppt/slides/slide4.xml><?xml version="1.0" encoding="utf-8"?>
-<p:sld xmlns:a="http://schemas.openxmlformats.org/drawingml/2006/main" xmlns:p="http://schemas.openxmlformats.org/presentationml/2006/main" xmlns:r="http://schemas.openxmlformats.org/officeDocument/2006/relationships">
+<p:sld xmlns:a="http://schemas.openxmlformats.org/drawingml/2006/main" xmlns:r="http://schemas.openxmlformats.org/officeDocument/2006/relationships" xmlns:p="http://schemas.openxmlformats.org/presentationml/2006/main">
   <p:cSld>
     <p:bg>
       <p:bgPr>
@@ -4456,7 +4429,7 @@
 </file>
 
 <file path=ppt/slides/slide5.xml><?xml version="1.0" encoding="utf-8"?>
-<p:sld xmlns:a="http://schemas.openxmlformats.org/drawingml/2006/main" xmlns:p="http://schemas.openxmlformats.org/presentationml/2006/main" xmlns:r="http://schemas.openxmlformats.org/officeDocument/2006/relationships">
+<p:sld xmlns:a="http://schemas.openxmlformats.org/drawingml/2006/main" xmlns:r="http://schemas.openxmlformats.org/officeDocument/2006/relationships" xmlns:p="http://schemas.openxmlformats.org/presentationml/2006/main">
   <p:cSld>
     <p:bg>
       <p:bgPr>
@@ -4517,7 +4490,7 @@
 </file>
 
 <file path=ppt/slides/slide6.xml><?xml version="1.0" encoding="utf-8"?>
-<p:sld xmlns:a="http://schemas.openxmlformats.org/drawingml/2006/main" xmlns:p="http://schemas.openxmlformats.org/presentationml/2006/main" xmlns:r="http://schemas.openxmlformats.org/officeDocument/2006/relationships">
+<p:sld xmlns:a="http://schemas.openxmlformats.org/drawingml/2006/main" xmlns:r="http://schemas.openxmlformats.org/officeDocument/2006/relationships" xmlns:p="http://schemas.openxmlformats.org/presentationml/2006/main">
   <p:cSld>
     <p:bg>
       <p:bgPr>
@@ -4646,7 +4619,7 @@
 </file>
 
 <file path=ppt/slides/slide7.xml><?xml version="1.0" encoding="utf-8"?>
-<p:sld xmlns:a="http://schemas.openxmlformats.org/drawingml/2006/main" xmlns:p="http://schemas.openxmlformats.org/presentationml/2006/main" xmlns:r="http://schemas.openxmlformats.org/officeDocument/2006/relationships">
+<p:sld xmlns:a="http://schemas.openxmlformats.org/drawingml/2006/main" xmlns:r="http://schemas.openxmlformats.org/officeDocument/2006/relationships" xmlns:p="http://schemas.openxmlformats.org/presentationml/2006/main">
   <p:cSld>
     <p:bg>
       <p:bgPr>
@@ -4707,7 +4680,7 @@
 </file>
 
 <file path=ppt/slides/slide8.xml><?xml version="1.0" encoding="utf-8"?>
-<p:sld xmlns:a="http://schemas.openxmlformats.org/drawingml/2006/main" xmlns:p="http://schemas.openxmlformats.org/presentationml/2006/main" xmlns:r="http://schemas.openxmlformats.org/officeDocument/2006/relationships">
+<p:sld xmlns:a="http://schemas.openxmlformats.org/drawingml/2006/main" xmlns:r="http://schemas.openxmlformats.org/officeDocument/2006/relationships" xmlns:p="http://schemas.openxmlformats.org/presentationml/2006/main">
   <p:cSld>
     <p:bg>
       <p:bgPr>
@@ -4821,7 +4794,7 @@
 </file>
 
 <file path=ppt/slides/slide9.xml><?xml version="1.0" encoding="utf-8"?>
-<p:sld xmlns:a="http://schemas.openxmlformats.org/drawingml/2006/main" xmlns:p="http://schemas.openxmlformats.org/presentationml/2006/main" xmlns:r="http://schemas.openxmlformats.org/officeDocument/2006/relationships">
+<p:sld xmlns:a="http://schemas.openxmlformats.org/drawingml/2006/main" xmlns:r="http://schemas.openxmlformats.org/officeDocument/2006/relationships" xmlns:p="http://schemas.openxmlformats.org/presentationml/2006/main">
   <p:cSld>
     <p:bg>
       <p:bgPr>
@@ -5280,6 +5253,10 @@
       </a:style>
     </a:lnDef>
   </a:objectDefaults>
-  <a:extraClrSchemeLst/>
+  <a:extLst>
+    <a:ext uri="{05A4C25C-085E-4340-85A3-A5531E510DB2}">
+      <thm15:themeFamily xmlns:thm15="http://schemas.microsoft.com/office/thememl/2012/main" name="Office Theme" id="{62F939B6-93AF-4DB8-9C6B-D6C7DFDC589F}" vid="{4A3C46E8-61CC-4603-A589-7422A47A8E4A}"/>
+    </a:ext>
+  </a:extLst>
 </a:theme>
 </file>
</xml_diff>